<commit_message>
Major advances in documentation:
- Simplifying images references: now tables and workflows are defined as rst table objects.
- Creating custom ccs file for handling color combinations in tabs.
- Completing all user guide detailed step modules.
- Revising installation.rst, resources.rst, tutorials.rst, user_guide.rst.
- Putting all examples references within the tutorial/ directory. Still WIP.
</commit_message>
<xml_diff>
--- a/docs/images/flowchart.pptx
+++ b/docs/images/flowchart.pptx
@@ -246,7 +246,7 @@
           <a:p>
             <a:fld id="{C4BA104D-BBF9-4279-8CEB-A5CF88D2DFAC}" type="datetimeFigureOut">
               <a:rPr lang="en-US" smtClean="0"/>
-              <a:t>3/24/2026</a:t>
+              <a:t>3/26/2026</a:t>
             </a:fld>
             <a:endParaRPr lang="en-US"/>
           </a:p>
@@ -416,7 +416,7 @@
           <a:p>
             <a:fld id="{C4BA104D-BBF9-4279-8CEB-A5CF88D2DFAC}" type="datetimeFigureOut">
               <a:rPr lang="en-US" smtClean="0"/>
-              <a:t>3/24/2026</a:t>
+              <a:t>3/26/2026</a:t>
             </a:fld>
             <a:endParaRPr lang="en-US"/>
           </a:p>
@@ -596,7 +596,7 @@
           <a:p>
             <a:fld id="{C4BA104D-BBF9-4279-8CEB-A5CF88D2DFAC}" type="datetimeFigureOut">
               <a:rPr lang="en-US" smtClean="0"/>
-              <a:t>3/24/2026</a:t>
+              <a:t>3/26/2026</a:t>
             </a:fld>
             <a:endParaRPr lang="en-US"/>
           </a:p>
@@ -896,7 +896,7 @@
           <a:p>
             <a:fld id="{C4BA104D-BBF9-4279-8CEB-A5CF88D2DFAC}" type="datetimeFigureOut">
               <a:rPr lang="en-US" smtClean="0"/>
-              <a:t>3/24/2026</a:t>
+              <a:t>3/26/2026</a:t>
             </a:fld>
             <a:endParaRPr lang="en-US"/>
           </a:p>
@@ -1142,7 +1142,7 @@
           <a:p>
             <a:fld id="{C4BA104D-BBF9-4279-8CEB-A5CF88D2DFAC}" type="datetimeFigureOut">
               <a:rPr lang="en-US" smtClean="0"/>
-              <a:t>3/24/2026</a:t>
+              <a:t>3/26/2026</a:t>
             </a:fld>
             <a:endParaRPr lang="en-US"/>
           </a:p>
@@ -1374,7 +1374,7 @@
           <a:p>
             <a:fld id="{C4BA104D-BBF9-4279-8CEB-A5CF88D2DFAC}" type="datetimeFigureOut">
               <a:rPr lang="en-US" smtClean="0"/>
-              <a:t>3/24/2026</a:t>
+              <a:t>3/26/2026</a:t>
             </a:fld>
             <a:endParaRPr lang="en-US"/>
           </a:p>
@@ -1741,7 +1741,7 @@
           <a:p>
             <a:fld id="{C4BA104D-BBF9-4279-8CEB-A5CF88D2DFAC}" type="datetimeFigureOut">
               <a:rPr lang="en-US" smtClean="0"/>
-              <a:t>3/24/2026</a:t>
+              <a:t>3/26/2026</a:t>
             </a:fld>
             <a:endParaRPr lang="en-US"/>
           </a:p>
@@ -1859,7 +1859,7 @@
           <a:p>
             <a:fld id="{C4BA104D-BBF9-4279-8CEB-A5CF88D2DFAC}" type="datetimeFigureOut">
               <a:rPr lang="en-US" smtClean="0"/>
-              <a:t>3/24/2026</a:t>
+              <a:t>3/26/2026</a:t>
             </a:fld>
             <a:endParaRPr lang="en-US"/>
           </a:p>
@@ -1954,7 +1954,7 @@
           <a:p>
             <a:fld id="{C4BA104D-BBF9-4279-8CEB-A5CF88D2DFAC}" type="datetimeFigureOut">
               <a:rPr lang="en-US" smtClean="0"/>
-              <a:t>3/24/2026</a:t>
+              <a:t>3/26/2026</a:t>
             </a:fld>
             <a:endParaRPr lang="en-US"/>
           </a:p>
@@ -2231,7 +2231,7 @@
           <a:p>
             <a:fld id="{C4BA104D-BBF9-4279-8CEB-A5CF88D2DFAC}" type="datetimeFigureOut">
               <a:rPr lang="en-US" smtClean="0"/>
-              <a:t>3/24/2026</a:t>
+              <a:t>3/26/2026</a:t>
             </a:fld>
             <a:endParaRPr lang="en-US"/>
           </a:p>
@@ -2488,7 +2488,7 @@
           <a:p>
             <a:fld id="{C4BA104D-BBF9-4279-8CEB-A5CF88D2DFAC}" type="datetimeFigureOut">
               <a:rPr lang="en-US" smtClean="0"/>
-              <a:t>3/24/2026</a:t>
+              <a:t>3/26/2026</a:t>
             </a:fld>
             <a:endParaRPr lang="en-US"/>
           </a:p>
@@ -2701,7 +2701,7 @@
           <a:p>
             <a:fld id="{C4BA104D-BBF9-4279-8CEB-A5CF88D2DFAC}" type="datetimeFigureOut">
               <a:rPr lang="en-US" smtClean="0"/>
-              <a:t>3/24/2026</a:t>
+              <a:t>3/26/2026</a:t>
             </a:fld>
             <a:endParaRPr lang="en-US"/>
           </a:p>
@@ -8253,8 +8253,8 @@
           </a:extLst>
         </p:spPr>
       </p:pic>
-      <mc:AlternateContent xmlns:mc="http://schemas.openxmlformats.org/markup-compatibility/2006">
-        <mc:Choice xmlns:a14="http://schemas.microsoft.com/office/drawing/2010/main" Requires="a14">
+      <mc:AlternateContent xmlns:mc="http://schemas.openxmlformats.org/markup-compatibility/2006" xmlns:a14="http://schemas.microsoft.com/office/drawing/2010/main">
+        <mc:Choice Requires="a14">
           <p:sp>
             <p:nvSpPr>
               <p:cNvPr id="5" name="TextBox 14">
@@ -8416,7 +8416,7 @@
             </p:txBody>
           </p:sp>
         </mc:Choice>
-        <mc:Fallback>
+        <mc:Fallback xmlns="">
           <p:sp>
             <p:nvSpPr>
               <p:cNvPr id="5" name="TextBox 14">
@@ -9761,8 +9761,8 @@
           </a:fontRef>
         </p:style>
       </p:cxnSp>
-      <mc:AlternateContent xmlns:mc="http://schemas.openxmlformats.org/markup-compatibility/2006">
-        <mc:Choice xmlns:a14="http://schemas.microsoft.com/office/drawing/2010/main" Requires="a14">
+      <mc:AlternateContent xmlns:mc="http://schemas.openxmlformats.org/markup-compatibility/2006" xmlns:a14="http://schemas.microsoft.com/office/drawing/2010/main">
+        <mc:Choice Requires="a14">
           <p:sp>
             <p:nvSpPr>
               <p:cNvPr id="22" name="TextBox 78">
@@ -9918,7 +9918,7 @@
             </p:txBody>
           </p:sp>
         </mc:Choice>
-        <mc:Fallback>
+        <mc:Fallback xmlns="">
           <p:sp>
             <p:nvSpPr>
               <p:cNvPr id="22" name="TextBox 78">
@@ -11032,8 +11032,8 @@
           </a:fontRef>
         </p:style>
       </p:cxnSp>
-      <mc:AlternateContent xmlns:mc="http://schemas.openxmlformats.org/markup-compatibility/2006">
-        <mc:Choice xmlns:a14="http://schemas.microsoft.com/office/drawing/2010/main" Requires="a14">
+      <mc:AlternateContent xmlns:mc="http://schemas.openxmlformats.org/markup-compatibility/2006" xmlns:a14="http://schemas.microsoft.com/office/drawing/2010/main">
+        <mc:Choice Requires="a14">
           <p:sp>
             <p:nvSpPr>
               <p:cNvPr id="35" name="TextBox 8">
@@ -11189,7 +11189,7 @@
             </p:txBody>
           </p:sp>
         </mc:Choice>
-        <mc:Fallback>
+        <mc:Fallback xmlns="">
           <p:sp>
             <p:nvSpPr>
               <p:cNvPr id="35" name="TextBox 8">
@@ -14415,66 +14415,6 @@
           </a:p>
         </p:txBody>
       </p:sp>
-      <p:pic>
-        <p:nvPicPr>
-          <p:cNvPr id="3" name="Picture 2">
-            <a:extLst>
-              <a:ext uri="{FF2B5EF4-FFF2-40B4-BE49-F238E27FC236}">
-                <a16:creationId xmlns:a16="http://schemas.microsoft.com/office/drawing/2014/main" id="{28D1FC85-C025-F263-D11D-A7E19D908F2B}"/>
-              </a:ext>
-            </a:extLst>
-          </p:cNvPr>
-          <p:cNvPicPr>
-            <a:picLocks noChangeAspect="1"/>
-          </p:cNvPicPr>
-          <p:nvPr/>
-        </p:nvPicPr>
-        <p:blipFill>
-          <a:blip r:embed="rId2"/>
-          <a:stretch>
-            <a:fillRect/>
-          </a:stretch>
-        </p:blipFill>
-        <p:spPr>
-          <a:xfrm>
-            <a:off x="7383712" y="3246447"/>
-            <a:ext cx="6693988" cy="6346486"/>
-          </a:xfrm>
-          <a:prstGeom prst="rect">
-            <a:avLst/>
-          </a:prstGeom>
-        </p:spPr>
-      </p:pic>
-      <p:pic>
-        <p:nvPicPr>
-          <p:cNvPr id="8" name="Picture 7">
-            <a:extLst>
-              <a:ext uri="{FF2B5EF4-FFF2-40B4-BE49-F238E27FC236}">
-                <a16:creationId xmlns:a16="http://schemas.microsoft.com/office/drawing/2014/main" id="{BD1CC652-94AE-9F04-A635-CAF2E459D4CD}"/>
-              </a:ext>
-            </a:extLst>
-          </p:cNvPr>
-          <p:cNvPicPr>
-            <a:picLocks noChangeAspect="1"/>
-          </p:cNvPicPr>
-          <p:nvPr/>
-        </p:nvPicPr>
-        <p:blipFill>
-          <a:blip r:embed="rId3"/>
-          <a:stretch>
-            <a:fillRect/>
-          </a:stretch>
-        </p:blipFill>
-        <p:spPr>
-          <a:xfrm>
-            <a:off x="6605958" y="10335319"/>
-            <a:ext cx="7437765" cy="3218967"/>
-          </a:xfrm>
-          <a:prstGeom prst="rect">
-            <a:avLst/>
-          </a:prstGeom>
-        </p:spPr>
-      </p:pic>
     </p:spTree>
     <p:extLst>
       <p:ext uri="{BB962C8B-B14F-4D97-AF65-F5344CB8AC3E}">

</xml_diff>